<commit_message>
sd-02-019/021: stages are a toolchain, not a per-change order; AMI rollback has limits; GraphQL only replaces shape-only scripts
Co-Authored-By: Claude Opus 5.5 <noreply@anthropic.com>
Claude-Session: https://claude.ai/code/session_01McBLtMnJbTnB94NeVs8a2V
</commit_message>
<xml_diff>
--- a/system-design-101/vi/lessons/sd-02-019/slides/sd-02-019.pptx
+++ b/system-design-101/vi/lessons/sd-02-019/slides/sd-02-019.pptx
@@ -4804,10 +4804,10 @@
                 <a:ea typeface="Bricolage Grotesque ExtraBold" pitchFamily="34" charset="-122"/>
                 <a:cs typeface="Bricolage Grotesque ExtraBold" pitchFamily="34" charset="-120"/>
               </a:rPr>
-              <a:t>chặng của</a:t>
-            </a:r>
-            <a:r>
-              <a:rPr lang="en-US" sz="4800" dirty="0" spc="-6" kern="0">
+              <a:t>chặng</a:t>
+            </a:r>
+            <a:r>
+              <a:rPr lang="en-US" sz="4800" dirty="0" spc="-11" kern="0">
                 <a:solidFill>
                   <a:srgbClr val="F3EEE3"/>
                 </a:solidFill>
@@ -4815,10 +4815,10 @@
                 <a:ea typeface="Bricolage Grotesque ExtraBold" pitchFamily="34" charset="-122"/>
                 <a:cs typeface="Bricolage Grotesque ExtraBold" pitchFamily="34" charset="-120"/>
               </a:rPr>
-              <a:t> một</a:t>
-            </a:r>
-            <a:r>
-              <a:rPr lang="en-US" sz="4800" dirty="0" spc="0" kern="0">
+              <a:t> trong</a:t>
+            </a:r>
+            <a:r>
+              <a:rPr lang="en-US" sz="4800" dirty="0" spc="-2" kern="0">
                 <a:solidFill>
                   <a:srgbClr val="F3EEE3"/>
                 </a:solidFill>
@@ -4826,10 +4826,10 @@
                 <a:ea typeface="Bricolage Grotesque ExtraBold" pitchFamily="34" charset="-122"/>
                 <a:cs typeface="Bricolage Grotesque ExtraBold" pitchFamily="34" charset="-120"/>
               </a:rPr>
-              <a:t> thay</a:t>
-            </a:r>
-            <a:r>
-              <a:rPr lang="en-US" sz="4800" dirty="0" spc="8" kern="0">
+              <a:t> chuỗi</a:t>
+            </a:r>
+            <a:r>
+              <a:rPr lang="en-US" sz="4800" dirty="0" spc="-18" kern="0">
                 <a:solidFill>
                   <a:srgbClr val="F3EEE3"/>
                 </a:solidFill>
@@ -4837,7 +4837,7 @@
                 <a:ea typeface="Bricolage Grotesque ExtraBold" pitchFamily="34" charset="-122"/>
                 <a:cs typeface="Bricolage Grotesque ExtraBold" pitchFamily="34" charset="-120"/>
               </a:rPr>
-              <a:t> đổi</a:t>
+              <a:t> CI/CD</a:t>
             </a:r>
             <a:endParaRPr lang="en-US" sz="4800" dirty="0"/>
           </a:p>
@@ -8187,10 +8187,10 @@
                 <a:ea typeface="Bricolage Grotesque ExtraBold" pitchFamily="34" charset="-122"/>
                 <a:cs typeface="Bricolage Grotesque ExtraBold" pitchFamily="34" charset="-120"/>
               </a:rPr>
-              <a:t>Công cụ</a:t>
-            </a:r>
-            <a:r>
-              <a:rPr lang="en-US" sz="4800" dirty="0" spc="-11" kern="0">
+              <a:t>Gây</a:t>
+            </a:r>
+            <a:r>
+              <a:rPr lang="en-US" sz="4800" dirty="0" spc="-2" kern="0">
                 <a:solidFill>
                   <a:srgbClr val="F3EEE3"/>
                 </a:solidFill>
@@ -8198,10 +8198,10 @@
                 <a:ea typeface="Bricolage Grotesque ExtraBold" pitchFamily="34" charset="-122"/>
                 <a:cs typeface="Bricolage Grotesque ExtraBold" pitchFamily="34" charset="-120"/>
               </a:rPr>
-              <a:t> gây</a:t>
-            </a:r>
-            <a:r>
-              <a:rPr lang="en-US" sz="4800" dirty="0" spc="-2" kern="0">
+              <a:t> hỗn</a:t>
+            </a:r>
+            <a:r>
+              <a:rPr lang="en-US" sz="4800" dirty="0" spc="-8" kern="0">
                 <a:solidFill>
                   <a:srgbClr val="F3EEE3"/>
                 </a:solidFill>
@@ -8209,10 +8209,10 @@
                 <a:ea typeface="Bricolage Grotesque ExtraBold" pitchFamily="34" charset="-122"/>
                 <a:cs typeface="Bricolage Grotesque ExtraBold" pitchFamily="34" charset="-120"/>
               </a:rPr>
-              <a:t> hỗn</a:t>
-            </a:r>
-            <a:r>
-              <a:rPr lang="en-US" sz="4800" dirty="0" spc="-8" kern="0">
+              <a:t> loạn</a:t>
+            </a:r>
+            <a:r>
+              <a:rPr lang="en-US" sz="4800" dirty="0" spc="-10" kern="0">
                 <a:solidFill>
                   <a:srgbClr val="F3EEE3"/>
                 </a:solidFill>
@@ -8220,7 +8220,51 @@
                 <a:ea typeface="Bricolage Grotesque ExtraBold" pitchFamily="34" charset="-122"/>
                 <a:cs typeface="Bricolage Grotesque ExtraBold" pitchFamily="34" charset="-120"/>
               </a:rPr>
-              <a:t> loạn</a:t>
+              <a:t> trên</a:t>
+            </a:r>
+            <a:r>
+              <a:rPr lang="en-US" sz="4800" dirty="0" spc="0" kern="0">
+                <a:solidFill>
+                  <a:srgbClr val="F3EEE3"/>
+                </a:solidFill>
+                <a:latin typeface="Bricolage Grotesque ExtraBold" pitchFamily="34" charset="0"/>
+                <a:ea typeface="Bricolage Grotesque ExtraBold" pitchFamily="34" charset="-122"/>
+                <a:cs typeface="Bricolage Grotesque ExtraBold" pitchFamily="34" charset="-120"/>
+              </a:rPr>
+              <a:t> hệ</a:t>
+            </a:r>
+            <a:r>
+              <a:rPr lang="en-US" sz="4800" dirty="0" spc="-1" kern="0">
+                <a:solidFill>
+                  <a:srgbClr val="F3EEE3"/>
+                </a:solidFill>
+                <a:latin typeface="Bricolage Grotesque ExtraBold" pitchFamily="34" charset="0"/>
+                <a:ea typeface="Bricolage Grotesque ExtraBold" pitchFamily="34" charset="-122"/>
+                <a:cs typeface="Bricolage Grotesque ExtraBold" pitchFamily="34" charset="-120"/>
+              </a:rPr>
+              <a:t> thống</a:t>
+            </a:r>
+            <a:r>
+              <a:rPr lang="en-US" sz="4800" dirty="0" spc="4" kern="0">
+                <a:solidFill>
+                  <a:srgbClr val="F3EEE3"/>
+                </a:solidFill>
+                <a:latin typeface="Bricolage Grotesque ExtraBold" pitchFamily="34" charset="0"/>
+                <a:ea typeface="Bricolage Grotesque ExtraBold" pitchFamily="34" charset="-122"/>
+                <a:cs typeface="Bricolage Grotesque ExtraBold" pitchFamily="34" charset="-120"/>
+              </a:rPr>
+              <a:t> đang</a:t>
+            </a:r>
+            <a:r>
+              <a:rPr lang="en-US" sz="4800" dirty="0" spc="-1" kern="0">
+                <a:solidFill>
+                  <a:srgbClr val="F3EEE3"/>
+                </a:solidFill>
+                <a:latin typeface="Bricolage Grotesque ExtraBold" pitchFamily="34" charset="0"/>
+                <a:ea typeface="Bricolage Grotesque ExtraBold" pitchFamily="34" charset="-122"/>
+                <a:cs typeface="Bricolage Grotesque ExtraBold" pitchFamily="34" charset="-120"/>
+              </a:rPr>
+              <a:t> chạy</a:t>
             </a:r>
             <a:endParaRPr lang="en-US" sz="4800" dirty="0"/>
           </a:p>
@@ -12147,7 +12191,7 @@
               <a:buNone/>
             </a:pPr>
             <a:r>
-              <a:rPr lang="en-US" sz="2250" b="1" dirty="0" spc="-8" kern="0">
+              <a:rPr lang="en-US" sz="2250" b="1" dirty="0" spc="7" kern="0">
                 <a:solidFill>
                   <a:srgbClr val="1F3FD1"/>
                 </a:solidFill>
@@ -12155,10 +12199,10 @@
                 <a:ea typeface="Be Vietnam Pro" pitchFamily="34" charset="-122"/>
                 <a:cs typeface="Be Vietnam Pro" pitchFamily="34" charset="-120"/>
               </a:rPr>
-              <a:t>Không</a:t>
-            </a:r>
-            <a:r>
-              <a:rPr lang="en-US" sz="2250" b="1" dirty="0" spc="14" kern="0">
+              <a:t>Cấu</a:t>
+            </a:r>
+            <a:r>
+              <a:rPr lang="en-US" sz="2250" b="1" dirty="0" spc="3" kern="0">
                 <a:solidFill>
                   <a:srgbClr val="1F3FD1"/>
                 </a:solidFill>
@@ -12166,10 +12210,10 @@
                 <a:ea typeface="Be Vietnam Pro" pitchFamily="34" charset="-122"/>
                 <a:cs typeface="Be Vietnam Pro" pitchFamily="34" charset="-120"/>
               </a:rPr>
-              <a:t> sửa</a:t>
-            </a:r>
-            <a:r>
-              <a:rPr lang="en-US" sz="2250" b="1" dirty="0" spc="-12" kern="0">
+              <a:t> hình,</a:t>
+            </a:r>
+            <a:r>
+              <a:rPr lang="en-US" sz="2250" b="1" dirty="0" spc="4" kern="0">
                 <a:solidFill>
                   <a:srgbClr val="1F3FD1"/>
                 </a:solidFill>
@@ -12177,10 +12221,10 @@
                 <a:ea typeface="Be Vietnam Pro" pitchFamily="34" charset="-122"/>
                 <a:cs typeface="Be Vietnam Pro" pitchFamily="34" charset="-120"/>
               </a:rPr>
-              <a:t> trên</a:t>
-            </a:r>
-            <a:r>
-              <a:rPr lang="en-US" sz="2250" b="1" dirty="0" spc="20" kern="0">
+              <a:t> dữ</a:t>
+            </a:r>
+            <a:r>
+              <a:rPr lang="en-US" sz="2250" b="1" dirty="0" spc="2" kern="0">
                 <a:solidFill>
                   <a:srgbClr val="1F3FD1"/>
                 </a:solidFill>
@@ -12188,10 +12232,10 @@
                 <a:ea typeface="Be Vietnam Pro" pitchFamily="34" charset="-122"/>
                 <a:cs typeface="Be Vietnam Pro" pitchFamily="34" charset="-120"/>
               </a:rPr>
-              <a:t> từng</a:t>
-            </a:r>
-            <a:r>
-              <a:rPr lang="en-US" sz="2250" b="1" dirty="0" spc="-5" kern="0">
+              <a:t> liệu:</a:t>
+            </a:r>
+            <a:r>
+              <a:rPr lang="en-US" sz="2250" b="1" dirty="0" spc="0" kern="0">
                 <a:solidFill>
                   <a:srgbClr val="1F3FD1"/>
                 </a:solidFill>
@@ -12199,7 +12243,40 @@
                 <a:ea typeface="Be Vietnam Pro" pitchFamily="34" charset="-122"/>
                 <a:cs typeface="Be Vietnam Pro" pitchFamily="34" charset="-120"/>
               </a:rPr>
-              <a:t> máy</a:t>
+              <a:t> cần</a:t>
+            </a:r>
+            <a:r>
+              <a:rPr lang="en-US" sz="2250" b="1" dirty="0" spc="-28" kern="0">
+                <a:solidFill>
+                  <a:srgbClr val="1F3FD1"/>
+                </a:solidFill>
+                <a:latin typeface="Be Vietnam Pro" pitchFamily="34" charset="0"/>
+                <a:ea typeface="Be Vietnam Pro" pitchFamily="34" charset="-122"/>
+                <a:cs typeface="Be Vietnam Pro" pitchFamily="34" charset="-120"/>
+              </a:rPr>
+              <a:t> kế</a:t>
+            </a:r>
+            <a:r>
+              <a:rPr lang="en-US" sz="2250" b="1" dirty="0" spc="3" kern="0">
+                <a:solidFill>
+                  <a:srgbClr val="1F3FD1"/>
+                </a:solidFill>
+                <a:latin typeface="Be Vietnam Pro" pitchFamily="34" charset="0"/>
+                <a:ea typeface="Be Vietnam Pro" pitchFamily="34" charset="-122"/>
+                <a:cs typeface="Be Vietnam Pro" pitchFamily="34" charset="-120"/>
+              </a:rPr>
+              <a:t> hoạch</a:t>
+            </a:r>
+            <a:r>
+              <a:rPr lang="en-US" sz="2250" b="1" dirty="0" spc="2" kern="0">
+                <a:solidFill>
+                  <a:srgbClr val="1F3FD1"/>
+                </a:solidFill>
+                <a:latin typeface="Be Vietnam Pro" pitchFamily="34" charset="0"/>
+                <a:ea typeface="Be Vietnam Pro" pitchFamily="34" charset="-122"/>
+                <a:cs typeface="Be Vietnam Pro" pitchFamily="34" charset="-120"/>
+              </a:rPr>
+              <a:t> riêng</a:t>
             </a:r>
             <a:endParaRPr lang="en-US" sz="2250" dirty="0"/>
           </a:p>

</xml_diff>